<commit_message>
fdeat: new panel layout for fig1
</commit_message>
<xml_diff>
--- a/figures/fig1/fig1.pptx
+++ b/figures/fig1/fig1.pptx
@@ -5,9 +5,9 @@
     <p:sldMasterId id="2147483648" r:id="rId1"/>
   </p:sldMasterIdLst>
   <p:sldIdLst>
-    <p:sldId id="256" r:id="rId7"/>
+    <p:sldId id="256" r:id="rId2"/>
   </p:sldIdLst>
-  <p:sldSz cx="5940000" cy="5688000" type="screen4x3"/>
+  <p:sldSz cx="5940425" cy="5688013"/>
   <p:notesSz cx="6858000" cy="9144000"/>
   <p:defaultTextStyle>
     <a:defPPr>
@@ -104,6 +104,22 @@
       </a:defRPr>
     </a:lvl9pPr>
   </p:defaultTextStyle>
+  <p:extLst>
+    <p:ext uri="{EFAFB233-063F-42B5-8137-9DF3F51BA10A}">
+      <p15:sldGuideLst xmlns:p15="http://schemas.microsoft.com/office/powerpoint/2012/main">
+        <p15:guide id="1" orient="horz" pos="2160">
+          <p15:clr>
+            <a:srgbClr val="A4A3A4"/>
+          </p15:clr>
+        </p15:guide>
+        <p15:guide id="2" pos="2880">
+          <p15:clr>
+            <a:srgbClr val="A4A3A4"/>
+          </p15:clr>
+        </p15:guide>
+      </p15:sldGuideLst>
+    </p:ext>
+  </p:extLst>
 </p:presentation>
 </file>
 
@@ -145,10 +161,9 @@
           <a:lstStyle/>
           <a:p>
             <a:r>
-              <a:rPr lang="en-US" smtClean="0"/>
+              <a:rPr lang="en-US"/>
               <a:t>Click to edit Master title style</a:t>
             </a:r>
-            <a:endParaRPr lang="en-US"/>
           </a:p>
         </p:txBody>
       </p:sp>
@@ -264,10 +279,9 @@
           </a:lstStyle>
           <a:p>
             <a:r>
-              <a:rPr lang="en-US" smtClean="0"/>
+              <a:rPr lang="en-US"/>
               <a:t>Click to edit Master subtitle style</a:t>
             </a:r>
-            <a:endParaRPr lang="en-US"/>
           </a:p>
         </p:txBody>
       </p:sp>
@@ -288,7 +302,7 @@
           <a:p>
             <a:fld id="{5BCAD085-E8A6-8845-BD4E-CB4CCA059FC4}" type="datetimeFigureOut">
               <a:rPr lang="en-US" smtClean="0"/>
-              <a:t>1/27/13</a:t>
+              <a:t>10/15/2026</a:t>
             </a:fld>
             <a:endParaRPr lang="en-US"/>
           </a:p>
@@ -382,10 +396,9 @@
           <a:lstStyle/>
           <a:p>
             <a:r>
-              <a:rPr lang="en-US" smtClean="0"/>
+              <a:rPr lang="en-US"/>
               <a:t>Click to edit Master title style</a:t>
             </a:r>
-            <a:endParaRPr lang="en-US"/>
           </a:p>
         </p:txBody>
       </p:sp>
@@ -406,38 +419,37 @@
           <a:p>
             <a:pPr lvl="0"/>
             <a:r>
-              <a:rPr lang="en-US" smtClean="0"/>
+              <a:rPr lang="en-US"/>
               <a:t>Click to edit Master text styles</a:t>
             </a:r>
           </a:p>
           <a:p>
             <a:pPr lvl="1"/>
             <a:r>
-              <a:rPr lang="en-US" smtClean="0"/>
+              <a:rPr lang="en-US"/>
               <a:t>Second level</a:t>
             </a:r>
           </a:p>
           <a:p>
             <a:pPr lvl="2"/>
             <a:r>
-              <a:rPr lang="en-US" smtClean="0"/>
+              <a:rPr lang="en-US"/>
               <a:t>Third level</a:t>
             </a:r>
           </a:p>
           <a:p>
             <a:pPr lvl="3"/>
             <a:r>
-              <a:rPr lang="en-US" smtClean="0"/>
+              <a:rPr lang="en-US"/>
               <a:t>Fourth level</a:t>
             </a:r>
           </a:p>
           <a:p>
             <a:pPr lvl="4"/>
             <a:r>
-              <a:rPr lang="en-US" smtClean="0"/>
+              <a:rPr lang="en-US"/>
               <a:t>Fifth level</a:t>
             </a:r>
-            <a:endParaRPr lang="en-US"/>
           </a:p>
         </p:txBody>
       </p:sp>
@@ -458,7 +470,7 @@
           <a:p>
             <a:fld id="{5BCAD085-E8A6-8845-BD4E-CB4CCA059FC4}" type="datetimeFigureOut">
               <a:rPr lang="en-US" smtClean="0"/>
-              <a:t>1/27/13</a:t>
+              <a:t>10/15/2026</a:t>
             </a:fld>
             <a:endParaRPr lang="en-US"/>
           </a:p>
@@ -557,10 +569,9 @@
           <a:lstStyle/>
           <a:p>
             <a:r>
-              <a:rPr lang="en-US" smtClean="0"/>
+              <a:rPr lang="en-US"/>
               <a:t>Click to edit Master title style</a:t>
             </a:r>
-            <a:endParaRPr lang="en-US"/>
           </a:p>
         </p:txBody>
       </p:sp>
@@ -586,38 +597,37 @@
           <a:p>
             <a:pPr lvl="0"/>
             <a:r>
-              <a:rPr lang="en-US" smtClean="0"/>
+              <a:rPr lang="en-US"/>
               <a:t>Click to edit Master text styles</a:t>
             </a:r>
           </a:p>
           <a:p>
             <a:pPr lvl="1"/>
             <a:r>
-              <a:rPr lang="en-US" smtClean="0"/>
+              <a:rPr lang="en-US"/>
               <a:t>Second level</a:t>
             </a:r>
           </a:p>
           <a:p>
             <a:pPr lvl="2"/>
             <a:r>
-              <a:rPr lang="en-US" smtClean="0"/>
+              <a:rPr lang="en-US"/>
               <a:t>Third level</a:t>
             </a:r>
           </a:p>
           <a:p>
             <a:pPr lvl="3"/>
             <a:r>
-              <a:rPr lang="en-US" smtClean="0"/>
+              <a:rPr lang="en-US"/>
               <a:t>Fourth level</a:t>
             </a:r>
           </a:p>
           <a:p>
             <a:pPr lvl="4"/>
             <a:r>
-              <a:rPr lang="en-US" smtClean="0"/>
+              <a:rPr lang="en-US"/>
               <a:t>Fifth level</a:t>
             </a:r>
-            <a:endParaRPr lang="en-US"/>
           </a:p>
         </p:txBody>
       </p:sp>
@@ -638,7 +648,7 @@
           <a:p>
             <a:fld id="{5BCAD085-E8A6-8845-BD4E-CB4CCA059FC4}" type="datetimeFigureOut">
               <a:rPr lang="en-US" smtClean="0"/>
-              <a:t>1/27/13</a:t>
+              <a:t>10/15/2026</a:t>
             </a:fld>
             <a:endParaRPr lang="en-US"/>
           </a:p>
@@ -732,10 +742,9 @@
           <a:lstStyle/>
           <a:p>
             <a:r>
-              <a:rPr lang="en-US" smtClean="0"/>
+              <a:rPr lang="en-US"/>
               <a:t>Click to edit Master title style</a:t>
             </a:r>
-            <a:endParaRPr lang="en-US"/>
           </a:p>
         </p:txBody>
       </p:sp>
@@ -756,38 +765,37 @@
           <a:p>
             <a:pPr lvl="0"/>
             <a:r>
-              <a:rPr lang="en-US" smtClean="0"/>
+              <a:rPr lang="en-US"/>
               <a:t>Click to edit Master text styles</a:t>
             </a:r>
           </a:p>
           <a:p>
             <a:pPr lvl="1"/>
             <a:r>
-              <a:rPr lang="en-US" smtClean="0"/>
+              <a:rPr lang="en-US"/>
               <a:t>Second level</a:t>
             </a:r>
           </a:p>
           <a:p>
             <a:pPr lvl="2"/>
             <a:r>
-              <a:rPr lang="en-US" smtClean="0"/>
+              <a:rPr lang="en-US"/>
               <a:t>Third level</a:t>
             </a:r>
           </a:p>
           <a:p>
             <a:pPr lvl="3"/>
             <a:r>
-              <a:rPr lang="en-US" smtClean="0"/>
+              <a:rPr lang="en-US"/>
               <a:t>Fourth level</a:t>
             </a:r>
           </a:p>
           <a:p>
             <a:pPr lvl="4"/>
             <a:r>
-              <a:rPr lang="en-US" smtClean="0"/>
+              <a:rPr lang="en-US"/>
               <a:t>Fifth level</a:t>
             </a:r>
-            <a:endParaRPr lang="en-US"/>
           </a:p>
         </p:txBody>
       </p:sp>
@@ -808,7 +816,7 @@
           <a:p>
             <a:fld id="{5BCAD085-E8A6-8845-BD4E-CB4CCA059FC4}" type="datetimeFigureOut">
               <a:rPr lang="en-US" smtClean="0"/>
-              <a:t>1/27/13</a:t>
+              <a:t>10/15/2026</a:t>
             </a:fld>
             <a:endParaRPr lang="en-US"/>
           </a:p>
@@ -911,10 +919,9 @@
           </a:lstStyle>
           <a:p>
             <a:r>
-              <a:rPr lang="en-US" smtClean="0"/>
+              <a:rPr lang="en-US"/>
               <a:t>Click to edit Master title style</a:t>
             </a:r>
-            <a:endParaRPr lang="en-US"/>
           </a:p>
         </p:txBody>
       </p:sp>
@@ -1031,7 +1038,7 @@
           <a:p>
             <a:pPr lvl="0"/>
             <a:r>
-              <a:rPr lang="en-US" smtClean="0"/>
+              <a:rPr lang="en-US"/>
               <a:t>Click to edit Master text styles</a:t>
             </a:r>
           </a:p>
@@ -1054,7 +1061,7 @@
           <a:p>
             <a:fld id="{5BCAD085-E8A6-8845-BD4E-CB4CCA059FC4}" type="datetimeFigureOut">
               <a:rPr lang="en-US" smtClean="0"/>
-              <a:t>1/27/13</a:t>
+              <a:t>10/15/2026</a:t>
             </a:fld>
             <a:endParaRPr lang="en-US"/>
           </a:p>
@@ -1148,10 +1155,9 @@
           <a:lstStyle/>
           <a:p>
             <a:r>
-              <a:rPr lang="en-US" smtClean="0"/>
+              <a:rPr lang="en-US"/>
               <a:t>Click to edit Master title style</a:t>
             </a:r>
-            <a:endParaRPr lang="en-US"/>
           </a:p>
         </p:txBody>
       </p:sp>
@@ -1205,38 +1211,37 @@
           <a:p>
             <a:pPr lvl="0"/>
             <a:r>
-              <a:rPr lang="en-US" smtClean="0"/>
+              <a:rPr lang="en-US"/>
               <a:t>Click to edit Master text styles</a:t>
             </a:r>
           </a:p>
           <a:p>
             <a:pPr lvl="1"/>
             <a:r>
-              <a:rPr lang="en-US" smtClean="0"/>
+              <a:rPr lang="en-US"/>
               <a:t>Second level</a:t>
             </a:r>
           </a:p>
           <a:p>
             <a:pPr lvl="2"/>
             <a:r>
-              <a:rPr lang="en-US" smtClean="0"/>
+              <a:rPr lang="en-US"/>
               <a:t>Third level</a:t>
             </a:r>
           </a:p>
           <a:p>
             <a:pPr lvl="3"/>
             <a:r>
-              <a:rPr lang="en-US" smtClean="0"/>
+              <a:rPr lang="en-US"/>
               <a:t>Fourth level</a:t>
             </a:r>
           </a:p>
           <a:p>
             <a:pPr lvl="4"/>
             <a:r>
-              <a:rPr lang="en-US" smtClean="0"/>
+              <a:rPr lang="en-US"/>
               <a:t>Fifth level</a:t>
             </a:r>
-            <a:endParaRPr lang="en-US"/>
           </a:p>
         </p:txBody>
       </p:sp>
@@ -1290,38 +1295,37 @@
           <a:p>
             <a:pPr lvl="0"/>
             <a:r>
-              <a:rPr lang="en-US" smtClean="0"/>
+              <a:rPr lang="en-US"/>
               <a:t>Click to edit Master text styles</a:t>
             </a:r>
           </a:p>
           <a:p>
             <a:pPr lvl="1"/>
             <a:r>
-              <a:rPr lang="en-US" smtClean="0"/>
+              <a:rPr lang="en-US"/>
               <a:t>Second level</a:t>
             </a:r>
           </a:p>
           <a:p>
             <a:pPr lvl="2"/>
             <a:r>
-              <a:rPr lang="en-US" smtClean="0"/>
+              <a:rPr lang="en-US"/>
               <a:t>Third level</a:t>
             </a:r>
           </a:p>
           <a:p>
             <a:pPr lvl="3"/>
             <a:r>
-              <a:rPr lang="en-US" smtClean="0"/>
+              <a:rPr lang="en-US"/>
               <a:t>Fourth level</a:t>
             </a:r>
           </a:p>
           <a:p>
             <a:pPr lvl="4"/>
             <a:r>
-              <a:rPr lang="en-US" smtClean="0"/>
+              <a:rPr lang="en-US"/>
               <a:t>Fifth level</a:t>
             </a:r>
-            <a:endParaRPr lang="en-US"/>
           </a:p>
         </p:txBody>
       </p:sp>
@@ -1342,7 +1346,7 @@
           <a:p>
             <a:fld id="{5BCAD085-E8A6-8845-BD4E-CB4CCA059FC4}" type="datetimeFigureOut">
               <a:rPr lang="en-US" smtClean="0"/>
-              <a:t>1/27/13</a:t>
+              <a:t>10/15/2026</a:t>
             </a:fld>
             <a:endParaRPr lang="en-US"/>
           </a:p>
@@ -1440,10 +1444,9 @@
           </a:lstStyle>
           <a:p>
             <a:r>
-              <a:rPr lang="en-US" smtClean="0"/>
+              <a:rPr lang="en-US"/>
               <a:t>Click to edit Master title style</a:t>
             </a:r>
-            <a:endParaRPr lang="en-US"/>
           </a:p>
         </p:txBody>
       </p:sp>
@@ -1506,7 +1509,7 @@
           <a:p>
             <a:pPr lvl="0"/>
             <a:r>
-              <a:rPr lang="en-US" smtClean="0"/>
+              <a:rPr lang="en-US"/>
               <a:t>Click to edit Master text styles</a:t>
             </a:r>
           </a:p>
@@ -1562,38 +1565,37 @@
           <a:p>
             <a:pPr lvl="0"/>
             <a:r>
-              <a:rPr lang="en-US" smtClean="0"/>
+              <a:rPr lang="en-US"/>
               <a:t>Click to edit Master text styles</a:t>
             </a:r>
           </a:p>
           <a:p>
             <a:pPr lvl="1"/>
             <a:r>
-              <a:rPr lang="en-US" smtClean="0"/>
+              <a:rPr lang="en-US"/>
               <a:t>Second level</a:t>
             </a:r>
           </a:p>
           <a:p>
             <a:pPr lvl="2"/>
             <a:r>
-              <a:rPr lang="en-US" smtClean="0"/>
+              <a:rPr lang="en-US"/>
               <a:t>Third level</a:t>
             </a:r>
           </a:p>
           <a:p>
             <a:pPr lvl="3"/>
             <a:r>
-              <a:rPr lang="en-US" smtClean="0"/>
+              <a:rPr lang="en-US"/>
               <a:t>Fourth level</a:t>
             </a:r>
           </a:p>
           <a:p>
             <a:pPr lvl="4"/>
             <a:r>
-              <a:rPr lang="en-US" smtClean="0"/>
+              <a:rPr lang="en-US"/>
               <a:t>Fifth level</a:t>
             </a:r>
-            <a:endParaRPr lang="en-US"/>
           </a:p>
         </p:txBody>
       </p:sp>
@@ -1656,7 +1658,7 @@
           <a:p>
             <a:pPr lvl="0"/>
             <a:r>
-              <a:rPr lang="en-US" smtClean="0"/>
+              <a:rPr lang="en-US"/>
               <a:t>Click to edit Master text styles</a:t>
             </a:r>
           </a:p>
@@ -1712,38 +1714,37 @@
           <a:p>
             <a:pPr lvl="0"/>
             <a:r>
-              <a:rPr lang="en-US" smtClean="0"/>
+              <a:rPr lang="en-US"/>
               <a:t>Click to edit Master text styles</a:t>
             </a:r>
           </a:p>
           <a:p>
             <a:pPr lvl="1"/>
             <a:r>
-              <a:rPr lang="en-US" smtClean="0"/>
+              <a:rPr lang="en-US"/>
               <a:t>Second level</a:t>
             </a:r>
           </a:p>
           <a:p>
             <a:pPr lvl="2"/>
             <a:r>
-              <a:rPr lang="en-US" smtClean="0"/>
+              <a:rPr lang="en-US"/>
               <a:t>Third level</a:t>
             </a:r>
           </a:p>
           <a:p>
             <a:pPr lvl="3"/>
             <a:r>
-              <a:rPr lang="en-US" smtClean="0"/>
+              <a:rPr lang="en-US"/>
               <a:t>Fourth level</a:t>
             </a:r>
           </a:p>
           <a:p>
             <a:pPr lvl="4"/>
             <a:r>
-              <a:rPr lang="en-US" smtClean="0"/>
+              <a:rPr lang="en-US"/>
               <a:t>Fifth level</a:t>
             </a:r>
-            <a:endParaRPr lang="en-US"/>
           </a:p>
         </p:txBody>
       </p:sp>
@@ -1764,7 +1765,7 @@
           <a:p>
             <a:fld id="{5BCAD085-E8A6-8845-BD4E-CB4CCA059FC4}" type="datetimeFigureOut">
               <a:rPr lang="en-US" smtClean="0"/>
-              <a:t>1/27/13</a:t>
+              <a:t>10/15/2026</a:t>
             </a:fld>
             <a:endParaRPr lang="en-US"/>
           </a:p>
@@ -1858,10 +1859,9 @@
           <a:lstStyle/>
           <a:p>
             <a:r>
-              <a:rPr lang="en-US" smtClean="0"/>
+              <a:rPr lang="en-US"/>
               <a:t>Click to edit Master title style</a:t>
             </a:r>
-            <a:endParaRPr lang="en-US"/>
           </a:p>
         </p:txBody>
       </p:sp>
@@ -1882,7 +1882,7 @@
           <a:p>
             <a:fld id="{5BCAD085-E8A6-8845-BD4E-CB4CCA059FC4}" type="datetimeFigureOut">
               <a:rPr lang="en-US" smtClean="0"/>
-              <a:t>1/27/13</a:t>
+              <a:t>10/15/2026</a:t>
             </a:fld>
             <a:endParaRPr lang="en-US"/>
           </a:p>
@@ -1977,7 +1977,7 @@
           <a:p>
             <a:fld id="{5BCAD085-E8A6-8845-BD4E-CB4CCA059FC4}" type="datetimeFigureOut">
               <a:rPr lang="en-US" smtClean="0"/>
-              <a:t>1/27/13</a:t>
+              <a:t>10/15/2026</a:t>
             </a:fld>
             <a:endParaRPr lang="en-US"/>
           </a:p>
@@ -2080,10 +2080,9 @@
           </a:lstStyle>
           <a:p>
             <a:r>
-              <a:rPr lang="en-US" smtClean="0"/>
+              <a:rPr lang="en-US"/>
               <a:t>Click to edit Master title style</a:t>
             </a:r>
-            <a:endParaRPr lang="en-US"/>
           </a:p>
         </p:txBody>
       </p:sp>
@@ -2137,38 +2136,37 @@
           <a:p>
             <a:pPr lvl="0"/>
             <a:r>
-              <a:rPr lang="en-US" smtClean="0"/>
+              <a:rPr lang="en-US"/>
               <a:t>Click to edit Master text styles</a:t>
             </a:r>
           </a:p>
           <a:p>
             <a:pPr lvl="1"/>
             <a:r>
-              <a:rPr lang="en-US" smtClean="0"/>
+              <a:rPr lang="en-US"/>
               <a:t>Second level</a:t>
             </a:r>
           </a:p>
           <a:p>
             <a:pPr lvl="2"/>
             <a:r>
-              <a:rPr lang="en-US" smtClean="0"/>
+              <a:rPr lang="en-US"/>
               <a:t>Third level</a:t>
             </a:r>
           </a:p>
           <a:p>
             <a:pPr lvl="3"/>
             <a:r>
-              <a:rPr lang="en-US" smtClean="0"/>
+              <a:rPr lang="en-US"/>
               <a:t>Fourth level</a:t>
             </a:r>
           </a:p>
           <a:p>
             <a:pPr lvl="4"/>
             <a:r>
-              <a:rPr lang="en-US" smtClean="0"/>
+              <a:rPr lang="en-US"/>
               <a:t>Fifth level</a:t>
             </a:r>
-            <a:endParaRPr lang="en-US"/>
           </a:p>
         </p:txBody>
       </p:sp>
@@ -2231,7 +2229,7 @@
           <a:p>
             <a:pPr lvl="0"/>
             <a:r>
-              <a:rPr lang="en-US" smtClean="0"/>
+              <a:rPr lang="en-US"/>
               <a:t>Click to edit Master text styles</a:t>
             </a:r>
           </a:p>
@@ -2254,7 +2252,7 @@
           <a:p>
             <a:fld id="{5BCAD085-E8A6-8845-BD4E-CB4CCA059FC4}" type="datetimeFigureOut">
               <a:rPr lang="en-US" smtClean="0"/>
-              <a:t>1/27/13</a:t>
+              <a:t>10/15/2026</a:t>
             </a:fld>
             <a:endParaRPr lang="en-US"/>
           </a:p>
@@ -2357,10 +2355,9 @@
           </a:lstStyle>
           <a:p>
             <a:r>
-              <a:rPr lang="en-US" smtClean="0"/>
+              <a:rPr lang="en-US"/>
               <a:t>Click to edit Master title style</a:t>
             </a:r>
-            <a:endParaRPr lang="en-US"/>
           </a:p>
         </p:txBody>
       </p:sp>
@@ -2484,7 +2481,7 @@
           <a:p>
             <a:pPr lvl="0"/>
             <a:r>
-              <a:rPr lang="en-US" smtClean="0"/>
+              <a:rPr lang="en-US"/>
               <a:t>Click to edit Master text styles</a:t>
             </a:r>
           </a:p>
@@ -2507,7 +2504,7 @@
           <a:p>
             <a:fld id="{5BCAD085-E8A6-8845-BD4E-CB4CCA059FC4}" type="datetimeFigureOut">
               <a:rPr lang="en-US" smtClean="0"/>
-              <a:t>1/27/13</a:t>
+              <a:t>10/15/2026</a:t>
             </a:fld>
             <a:endParaRPr lang="en-US"/>
           </a:p>
@@ -2616,10 +2613,9 @@
           <a:lstStyle/>
           <a:p>
             <a:r>
-              <a:rPr lang="en-US" smtClean="0"/>
+              <a:rPr lang="en-US"/>
               <a:t>Click to edit Master title style</a:t>
             </a:r>
-            <a:endParaRPr lang="en-US"/>
           </a:p>
         </p:txBody>
       </p:sp>
@@ -2650,38 +2646,37 @@
           <a:p>
             <a:pPr lvl="0"/>
             <a:r>
-              <a:rPr lang="en-US" smtClean="0"/>
+              <a:rPr lang="en-US"/>
               <a:t>Click to edit Master text styles</a:t>
             </a:r>
           </a:p>
           <a:p>
             <a:pPr lvl="1"/>
             <a:r>
-              <a:rPr lang="en-US" smtClean="0"/>
+              <a:rPr lang="en-US"/>
               <a:t>Second level</a:t>
             </a:r>
           </a:p>
           <a:p>
             <a:pPr lvl="2"/>
             <a:r>
-              <a:rPr lang="en-US" smtClean="0"/>
+              <a:rPr lang="en-US"/>
               <a:t>Third level</a:t>
             </a:r>
           </a:p>
           <a:p>
             <a:pPr lvl="3"/>
             <a:r>
-              <a:rPr lang="en-US" smtClean="0"/>
+              <a:rPr lang="en-US"/>
               <a:t>Fourth level</a:t>
             </a:r>
           </a:p>
           <a:p>
             <a:pPr lvl="4"/>
             <a:r>
-              <a:rPr lang="en-US" smtClean="0"/>
+              <a:rPr lang="en-US"/>
               <a:t>Fifth level</a:t>
             </a:r>
-            <a:endParaRPr lang="en-US"/>
           </a:p>
         </p:txBody>
       </p:sp>
@@ -2720,7 +2715,7 @@
           <a:p>
             <a:fld id="{5BCAD085-E8A6-8845-BD4E-CB4CCA059FC4}" type="datetimeFigureOut">
               <a:rPr lang="en-US" smtClean="0"/>
-              <a:t>1/27/13</a:t>
+              <a:t>10/15/2026</a:t>
             </a:fld>
             <a:endParaRPr lang="en-US"/>
           </a:p>
@@ -3079,7 +3074,7 @@
 </file>
 
 <file path=ppt/slides/slide1.xml><?xml version="1.0" encoding="utf-8"?>
-<p:sld xmlns:a="http://schemas.openxmlformats.org/drawingml/2006/main" xmlns:p="http://schemas.openxmlformats.org/presentationml/2006/main" xmlns:r="http://schemas.openxmlformats.org/officeDocument/2006/relationships">
+<p:sld xmlns:a="http://schemas.openxmlformats.org/drawingml/2006/main" xmlns:r="http://schemas.openxmlformats.org/officeDocument/2006/relationships" xmlns:p="http://schemas.openxmlformats.org/presentationml/2006/main">
   <p:cSld>
     <p:spTree>
       <p:nvGrpSpPr>
@@ -3087,7 +3082,410 @@
         <p:cNvGrpSpPr/>
         <p:nvPr/>
       </p:nvGrpSpPr>
-      <p:grpSpPr/>
+      <p:grpSpPr>
+        <a:xfrm>
+          <a:off x="0" y="0"/>
+          <a:ext cx="0" cy="0"/>
+          <a:chOff x="0" y="0"/>
+          <a:chExt cx="0" cy="0"/>
+        </a:xfrm>
+      </p:grpSpPr>
+      <p:sp>
+        <p:nvSpPr>
+          <p:cNvPr id="14" name="fig1_H">
+            <a:extLst>
+              <a:ext uri="{FF2B5EF4-FFF2-40B4-BE49-F238E27FC236}">
+                <a16:creationId xmlns:a16="http://schemas.microsoft.com/office/drawing/2014/main" id="{8C388E60-74BA-C247-ED30-69CF5931F5DE}"/>
+              </a:ext>
+            </a:extLst>
+          </p:cNvPr>
+          <p:cNvSpPr/>
+          <p:nvPr/>
+        </p:nvSpPr>
+        <p:spPr>
+          <a:xfrm>
+            <a:off x="2970212" y="4531599"/>
+            <a:ext cx="2117798" cy="990067"/>
+          </a:xfrm>
+          <a:prstGeom prst="rect">
+            <a:avLst/>
+          </a:prstGeom>
+          <a:solidFill>
+            <a:srgbClr val="D0F5F5"/>
+          </a:solidFill>
+          <a:ln w="6350">
+            <a:solidFill>
+              <a:srgbClr val="808080"/>
+            </a:solidFill>
+          </a:ln>
+        </p:spPr>
+        <p:style>
+          <a:lnRef idx="1">
+            <a:schemeClr val="accent1"/>
+          </a:lnRef>
+          <a:fillRef idx="3">
+            <a:schemeClr val="accent1"/>
+          </a:fillRef>
+          <a:effectRef idx="2">
+            <a:schemeClr val="accent1"/>
+          </a:effectRef>
+          <a:fontRef idx="minor">
+            <a:schemeClr val="lt1"/>
+          </a:fontRef>
+        </p:style>
+        <p:txBody>
+          <a:bodyPr wrap="none" rtlCol="0" anchor="ctr"/>
+          <a:lstStyle/>
+          <a:p>
+            <a:pPr algn="ctr"/>
+            <a:r>
+              <a:rPr sz="1000" b="1" dirty="0">
+                <a:solidFill>
+                  <a:srgbClr val="333333"/>
+                </a:solidFill>
+              </a:rPr>
+              <a:t>F
+52×55 mm</a:t>
+            </a:r>
+          </a:p>
+        </p:txBody>
+      </p:sp>
+      <p:sp>
+        <p:nvSpPr>
+          <p:cNvPr id="7" name="fig1_G"/>
+          <p:cNvSpPr/>
+          <p:nvPr/>
+        </p:nvSpPr>
+        <p:spPr>
+          <a:xfrm>
+            <a:off x="2970212" y="3462975"/>
+            <a:ext cx="2117798" cy="990067"/>
+          </a:xfrm>
+          <a:prstGeom prst="rect">
+            <a:avLst/>
+          </a:prstGeom>
+          <a:solidFill>
+            <a:srgbClr val="D0F5F5"/>
+          </a:solidFill>
+          <a:ln w="6350">
+            <a:solidFill>
+              <a:srgbClr val="808080"/>
+            </a:solidFill>
+          </a:ln>
+        </p:spPr>
+        <p:style>
+          <a:lnRef idx="1">
+            <a:schemeClr val="accent1"/>
+          </a:lnRef>
+          <a:fillRef idx="3">
+            <a:schemeClr val="accent1"/>
+          </a:fillRef>
+          <a:effectRef idx="2">
+            <a:schemeClr val="accent1"/>
+          </a:effectRef>
+          <a:fontRef idx="minor">
+            <a:schemeClr val="lt1"/>
+          </a:fontRef>
+        </p:style>
+        <p:txBody>
+          <a:bodyPr wrap="none" rtlCol="0" anchor="ctr"/>
+          <a:lstStyle/>
+          <a:p>
+            <a:pPr algn="ctr"/>
+            <a:r>
+              <a:rPr sz="1000" b="1" dirty="0">
+                <a:solidFill>
+                  <a:srgbClr val="333333"/>
+                </a:solidFill>
+              </a:rPr>
+              <a:t>F
+52×55 mm</a:t>
+            </a:r>
+          </a:p>
+        </p:txBody>
+      </p:sp>
+      <p:sp>
+        <p:nvSpPr>
+          <p:cNvPr id="5" name="fig1_F"/>
+          <p:cNvSpPr/>
+          <p:nvPr/>
+        </p:nvSpPr>
+        <p:spPr>
+          <a:xfrm>
+            <a:off x="2970212" y="2244969"/>
+            <a:ext cx="2117798" cy="1139449"/>
+          </a:xfrm>
+          <a:prstGeom prst="rect">
+            <a:avLst/>
+          </a:prstGeom>
+          <a:solidFill>
+            <a:srgbClr val="F0D0F0"/>
+          </a:solidFill>
+          <a:ln w="6350">
+            <a:solidFill>
+              <a:srgbClr val="808080"/>
+            </a:solidFill>
+          </a:ln>
+        </p:spPr>
+        <p:style>
+          <a:lnRef idx="1">
+            <a:schemeClr val="accent1"/>
+          </a:lnRef>
+          <a:fillRef idx="3">
+            <a:schemeClr val="accent1"/>
+          </a:fillRef>
+          <a:effectRef idx="2">
+            <a:schemeClr val="accent1"/>
+          </a:effectRef>
+          <a:fontRef idx="minor">
+            <a:schemeClr val="lt1"/>
+          </a:fontRef>
+        </p:style>
+        <p:txBody>
+          <a:bodyPr wrap="none" rtlCol="0" anchor="ctr"/>
+          <a:lstStyle/>
+          <a:p>
+            <a:pPr algn="ctr"/>
+            <a:r>
+              <a:rPr sz="1000" b="1">
+                <a:solidFill>
+                  <a:srgbClr val="333333"/>
+                </a:solidFill>
+              </a:rPr>
+              <a:t>D
+51×55 mm</a:t>
+            </a:r>
+          </a:p>
+        </p:txBody>
+      </p:sp>
+      <p:sp>
+        <p:nvSpPr>
+          <p:cNvPr id="12" name="fig1_E">
+            <a:extLst>
+              <a:ext uri="{FF2B5EF4-FFF2-40B4-BE49-F238E27FC236}">
+                <a16:creationId xmlns:a16="http://schemas.microsoft.com/office/drawing/2014/main" id="{E23DCF68-356D-89E5-360E-0972F29F2B3D}"/>
+              </a:ext>
+            </a:extLst>
+          </p:cNvPr>
+          <p:cNvSpPr/>
+          <p:nvPr/>
+        </p:nvSpPr>
+        <p:spPr>
+          <a:xfrm>
+            <a:off x="4339123" y="1536709"/>
+            <a:ext cx="748887" cy="671509"/>
+          </a:xfrm>
+          <a:prstGeom prst="rect">
+            <a:avLst/>
+          </a:prstGeom>
+          <a:solidFill>
+            <a:srgbClr val="D0F0E0"/>
+          </a:solidFill>
+          <a:ln w="6350">
+            <a:solidFill>
+              <a:srgbClr val="808080"/>
+            </a:solidFill>
+          </a:ln>
+        </p:spPr>
+        <p:style>
+          <a:lnRef idx="1">
+            <a:schemeClr val="accent1"/>
+          </a:lnRef>
+          <a:fillRef idx="3">
+            <a:schemeClr val="accent1"/>
+          </a:fillRef>
+          <a:effectRef idx="2">
+            <a:schemeClr val="accent1"/>
+          </a:effectRef>
+          <a:fontRef idx="minor">
+            <a:schemeClr val="lt1"/>
+          </a:fontRef>
+        </p:style>
+        <p:txBody>
+          <a:bodyPr wrap="none" rtlCol="0" anchor="ctr"/>
+          <a:lstStyle/>
+          <a:p>
+            <a:pPr algn="ctr"/>
+            <a:r>
+              <a:rPr sz="1000" b="1" dirty="0">
+                <a:solidFill>
+                  <a:srgbClr val="333333"/>
+                </a:solidFill>
+              </a:rPr>
+              <a:t>B
+52×55 mm</a:t>
+            </a:r>
+          </a:p>
+        </p:txBody>
+      </p:sp>
+      <p:sp>
+        <p:nvSpPr>
+          <p:cNvPr id="10" name="fig1_D">
+            <a:extLst>
+              <a:ext uri="{FF2B5EF4-FFF2-40B4-BE49-F238E27FC236}">
+                <a16:creationId xmlns:a16="http://schemas.microsoft.com/office/drawing/2014/main" id="{C741465E-251B-2D14-7AB8-017C5773C8AC}"/>
+              </a:ext>
+            </a:extLst>
+          </p:cNvPr>
+          <p:cNvSpPr/>
+          <p:nvPr/>
+        </p:nvSpPr>
+        <p:spPr>
+          <a:xfrm>
+            <a:off x="4339123" y="819608"/>
+            <a:ext cx="748887" cy="671509"/>
+          </a:xfrm>
+          <a:prstGeom prst="rect">
+            <a:avLst/>
+          </a:prstGeom>
+          <a:solidFill>
+            <a:srgbClr val="D0F0E0"/>
+          </a:solidFill>
+          <a:ln w="6350">
+            <a:solidFill>
+              <a:srgbClr val="808080"/>
+            </a:solidFill>
+          </a:ln>
+        </p:spPr>
+        <p:style>
+          <a:lnRef idx="1">
+            <a:schemeClr val="accent1"/>
+          </a:lnRef>
+          <a:fillRef idx="3">
+            <a:schemeClr val="accent1"/>
+          </a:fillRef>
+          <a:effectRef idx="2">
+            <a:schemeClr val="accent1"/>
+          </a:effectRef>
+          <a:fontRef idx="minor">
+            <a:schemeClr val="lt1"/>
+          </a:fontRef>
+        </p:style>
+        <p:txBody>
+          <a:bodyPr wrap="none" rtlCol="0" anchor="ctr"/>
+          <a:lstStyle/>
+          <a:p>
+            <a:pPr algn="ctr"/>
+            <a:r>
+              <a:rPr sz="1000" b="1">
+                <a:solidFill>
+                  <a:srgbClr val="333333"/>
+                </a:solidFill>
+              </a:rPr>
+              <a:t>B
+52×55 mm</a:t>
+            </a:r>
+          </a:p>
+        </p:txBody>
+      </p:sp>
+      <p:sp>
+        <p:nvSpPr>
+          <p:cNvPr id="3" name="fig1_C"/>
+          <p:cNvSpPr/>
+          <p:nvPr/>
+        </p:nvSpPr>
+        <p:spPr>
+          <a:xfrm>
+            <a:off x="4339123" y="60138"/>
+            <a:ext cx="748887" cy="713878"/>
+          </a:xfrm>
+          <a:prstGeom prst="rect">
+            <a:avLst/>
+          </a:prstGeom>
+          <a:solidFill>
+            <a:srgbClr val="D0F0E0"/>
+          </a:solidFill>
+          <a:ln w="6350">
+            <a:solidFill>
+              <a:srgbClr val="808080"/>
+            </a:solidFill>
+          </a:ln>
+        </p:spPr>
+        <p:style>
+          <a:lnRef idx="1">
+            <a:schemeClr val="accent1"/>
+          </a:lnRef>
+          <a:fillRef idx="3">
+            <a:schemeClr val="accent1"/>
+          </a:fillRef>
+          <a:effectRef idx="2">
+            <a:schemeClr val="accent1"/>
+          </a:effectRef>
+          <a:fontRef idx="minor">
+            <a:schemeClr val="lt1"/>
+          </a:fontRef>
+        </p:style>
+        <p:txBody>
+          <a:bodyPr wrap="none" rtlCol="0" anchor="ctr"/>
+          <a:lstStyle/>
+          <a:p>
+            <a:pPr algn="ctr"/>
+            <a:r>
+              <a:rPr sz="1000" b="1">
+                <a:solidFill>
+                  <a:srgbClr val="333333"/>
+                </a:solidFill>
+              </a:rPr>
+              <a:t>B
+52×55 mm</a:t>
+            </a:r>
+          </a:p>
+        </p:txBody>
+      </p:sp>
+      <p:sp>
+        <p:nvSpPr>
+          <p:cNvPr id="4" name="fig1_B"/>
+          <p:cNvSpPr/>
+          <p:nvPr/>
+        </p:nvSpPr>
+        <p:spPr>
+          <a:xfrm>
+            <a:off x="645012" y="2244969"/>
+            <a:ext cx="2265131" cy="3276697"/>
+          </a:xfrm>
+          <a:prstGeom prst="rect">
+            <a:avLst/>
+          </a:prstGeom>
+          <a:solidFill>
+            <a:srgbClr val="F5E8D0"/>
+          </a:solidFill>
+          <a:ln w="6350">
+            <a:solidFill>
+              <a:srgbClr val="808080"/>
+            </a:solidFill>
+          </a:ln>
+        </p:spPr>
+        <p:style>
+          <a:lnRef idx="1">
+            <a:schemeClr val="accent1"/>
+          </a:lnRef>
+          <a:fillRef idx="3">
+            <a:schemeClr val="accent1"/>
+          </a:fillRef>
+          <a:effectRef idx="2">
+            <a:schemeClr val="accent1"/>
+          </a:effectRef>
+          <a:fontRef idx="minor">
+            <a:schemeClr val="lt1"/>
+          </a:fontRef>
+        </p:style>
+        <p:txBody>
+          <a:bodyPr wrap="none" rtlCol="0" anchor="ctr"/>
+          <a:lstStyle/>
+          <a:p>
+            <a:pPr algn="ctr"/>
+            <a:r>
+              <a:rPr sz="1000" b="1">
+                <a:solidFill>
+                  <a:srgbClr val="333333"/>
+                </a:solidFill>
+              </a:rPr>
+              <a:t>C
+52×55 mm</a:t>
+            </a:r>
+          </a:p>
+        </p:txBody>
+      </p:sp>
       <p:sp>
         <p:nvSpPr>
           <p:cNvPr id="2" name="fig1_A"/>
@@ -3096,8 +3494,8 @@
         </p:nvSpPr>
         <p:spPr>
           <a:xfrm>
-            <a:off x="0" y="0"/>
-            <a:ext cx="5940000" cy="1368000"/>
+            <a:off x="645013" y="60137"/>
+            <a:ext cx="3650012" cy="2148081"/>
           </a:xfrm>
           <a:prstGeom prst="rect">
             <a:avLst/>
@@ -3126,342 +3524,18 @@
           </a:fontRef>
         </p:style>
         <p:txBody>
-          <a:bodyPr rtlCol="0" anchor="ctr" wrap="none"/>
+          <a:bodyPr wrap="none" rtlCol="0" anchor="ctr"/>
           <a:lstStyle/>
           <a:p>
             <a:pPr algn="ctr"/>
             <a:r>
-              <a:rPr sz="1000" b="1">
+              <a:rPr sz="1000" b="1" dirty="0">
                 <a:solidFill>
                   <a:srgbClr val="333333"/>
                 </a:solidFill>
               </a:rPr>
               <a:t>A
 165×38 mm</a:t>
-            </a:r>
-          </a:p>
-        </p:txBody>
-      </p:sp>
-      <p:sp>
-        <p:nvSpPr>
-          <p:cNvPr id="3" name="fig1_B"/>
-          <p:cNvSpPr/>
-          <p:nvPr/>
-        </p:nvSpPr>
-        <p:spPr>
-          <a:xfrm>
-            <a:off x="0" y="1548000"/>
-            <a:ext cx="1872000" cy="1980000"/>
-          </a:xfrm>
-          <a:prstGeom prst="rect">
-            <a:avLst/>
-          </a:prstGeom>
-          <a:solidFill>
-            <a:srgbClr val="D0F0E0"/>
-          </a:solidFill>
-          <a:ln w="6350">
-            <a:solidFill>
-              <a:srgbClr val="808080"/>
-            </a:solidFill>
-          </a:ln>
-        </p:spPr>
-        <p:style>
-          <a:lnRef idx="1">
-            <a:schemeClr val="accent1"/>
-          </a:lnRef>
-          <a:fillRef idx="3">
-            <a:schemeClr val="accent1"/>
-          </a:fillRef>
-          <a:effectRef idx="2">
-            <a:schemeClr val="accent1"/>
-          </a:effectRef>
-          <a:fontRef idx="minor">
-            <a:schemeClr val="lt1"/>
-          </a:fontRef>
-        </p:style>
-        <p:txBody>
-          <a:bodyPr rtlCol="0" anchor="ctr" wrap="none"/>
-          <a:lstStyle/>
-          <a:p>
-            <a:pPr algn="ctr"/>
-            <a:r>
-              <a:rPr sz="1000" b="1">
-                <a:solidFill>
-                  <a:srgbClr val="333333"/>
-                </a:solidFill>
-              </a:rPr>
-              <a:t>B
-52×55 mm</a:t>
-            </a:r>
-          </a:p>
-        </p:txBody>
-      </p:sp>
-      <p:sp>
-        <p:nvSpPr>
-          <p:cNvPr id="4" name="fig1_C"/>
-          <p:cNvSpPr/>
-          <p:nvPr/>
-        </p:nvSpPr>
-        <p:spPr>
-          <a:xfrm>
-            <a:off x="2052000" y="1548000"/>
-            <a:ext cx="1872000" cy="1980000"/>
-          </a:xfrm>
-          <a:prstGeom prst="rect">
-            <a:avLst/>
-          </a:prstGeom>
-          <a:solidFill>
-            <a:srgbClr val="F5E8D0"/>
-          </a:solidFill>
-          <a:ln w="6350">
-            <a:solidFill>
-              <a:srgbClr val="808080"/>
-            </a:solidFill>
-          </a:ln>
-        </p:spPr>
-        <p:style>
-          <a:lnRef idx="1">
-            <a:schemeClr val="accent1"/>
-          </a:lnRef>
-          <a:fillRef idx="3">
-            <a:schemeClr val="accent1"/>
-          </a:fillRef>
-          <a:effectRef idx="2">
-            <a:schemeClr val="accent1"/>
-          </a:effectRef>
-          <a:fontRef idx="minor">
-            <a:schemeClr val="lt1"/>
-          </a:fontRef>
-        </p:style>
-        <p:txBody>
-          <a:bodyPr rtlCol="0" anchor="ctr" wrap="none"/>
-          <a:lstStyle/>
-          <a:p>
-            <a:pPr algn="ctr"/>
-            <a:r>
-              <a:rPr sz="1000" b="1">
-                <a:solidFill>
-                  <a:srgbClr val="333333"/>
-                </a:solidFill>
-              </a:rPr>
-              <a:t>C
-52×55 mm</a:t>
-            </a:r>
-          </a:p>
-        </p:txBody>
-      </p:sp>
-      <p:sp>
-        <p:nvSpPr>
-          <p:cNvPr id="5" name="fig1_D"/>
-          <p:cNvSpPr/>
-          <p:nvPr/>
-        </p:nvSpPr>
-        <p:spPr>
-          <a:xfrm>
-            <a:off x="4104000" y="1548000"/>
-            <a:ext cx="1836000" cy="1980000"/>
-          </a:xfrm>
-          <a:prstGeom prst="rect">
-            <a:avLst/>
-          </a:prstGeom>
-          <a:solidFill>
-            <a:srgbClr val="F0D0F0"/>
-          </a:solidFill>
-          <a:ln w="6350">
-            <a:solidFill>
-              <a:srgbClr val="808080"/>
-            </a:solidFill>
-          </a:ln>
-        </p:spPr>
-        <p:style>
-          <a:lnRef idx="1">
-            <a:schemeClr val="accent1"/>
-          </a:lnRef>
-          <a:fillRef idx="3">
-            <a:schemeClr val="accent1"/>
-          </a:fillRef>
-          <a:effectRef idx="2">
-            <a:schemeClr val="accent1"/>
-          </a:effectRef>
-          <a:fontRef idx="minor">
-            <a:schemeClr val="lt1"/>
-          </a:fontRef>
-        </p:style>
-        <p:txBody>
-          <a:bodyPr rtlCol="0" anchor="ctr" wrap="none"/>
-          <a:lstStyle/>
-          <a:p>
-            <a:pPr algn="ctr"/>
-            <a:r>
-              <a:rPr sz="1000" b="1">
-                <a:solidFill>
-                  <a:srgbClr val="333333"/>
-                </a:solidFill>
-              </a:rPr>
-              <a:t>D
-51×55 mm</a:t>
-            </a:r>
-          </a:p>
-        </p:txBody>
-      </p:sp>
-      <p:sp>
-        <p:nvSpPr>
-          <p:cNvPr id="6" name="fig1_E"/>
-          <p:cNvSpPr/>
-          <p:nvPr/>
-        </p:nvSpPr>
-        <p:spPr>
-          <a:xfrm>
-            <a:off x="0" y="3708000"/>
-            <a:ext cx="1872000" cy="1980000"/>
-          </a:xfrm>
-          <a:prstGeom prst="rect">
-            <a:avLst/>
-          </a:prstGeom>
-          <a:solidFill>
-            <a:srgbClr val="F5F0D0"/>
-          </a:solidFill>
-          <a:ln w="6350">
-            <a:solidFill>
-              <a:srgbClr val="808080"/>
-            </a:solidFill>
-          </a:ln>
-        </p:spPr>
-        <p:style>
-          <a:lnRef idx="1">
-            <a:schemeClr val="accent1"/>
-          </a:lnRef>
-          <a:fillRef idx="3">
-            <a:schemeClr val="accent1"/>
-          </a:fillRef>
-          <a:effectRef idx="2">
-            <a:schemeClr val="accent1"/>
-          </a:effectRef>
-          <a:fontRef idx="minor">
-            <a:schemeClr val="lt1"/>
-          </a:fontRef>
-        </p:style>
-        <p:txBody>
-          <a:bodyPr rtlCol="0" anchor="ctr" wrap="none"/>
-          <a:lstStyle/>
-          <a:p>
-            <a:pPr algn="ctr"/>
-            <a:r>
-              <a:rPr sz="1000" b="1">
-                <a:solidFill>
-                  <a:srgbClr val="333333"/>
-                </a:solidFill>
-              </a:rPr>
-              <a:t>E
-52×55 mm</a:t>
-            </a:r>
-          </a:p>
-        </p:txBody>
-      </p:sp>
-      <p:sp>
-        <p:nvSpPr>
-          <p:cNvPr id="7" name="fig1_F"/>
-          <p:cNvSpPr/>
-          <p:nvPr/>
-        </p:nvSpPr>
-        <p:spPr>
-          <a:xfrm>
-            <a:off x="2052000" y="3708000"/>
-            <a:ext cx="1872000" cy="1980000"/>
-          </a:xfrm>
-          <a:prstGeom prst="rect">
-            <a:avLst/>
-          </a:prstGeom>
-          <a:solidFill>
-            <a:srgbClr val="D0F5F5"/>
-          </a:solidFill>
-          <a:ln w="6350">
-            <a:solidFill>
-              <a:srgbClr val="808080"/>
-            </a:solidFill>
-          </a:ln>
-        </p:spPr>
-        <p:style>
-          <a:lnRef idx="1">
-            <a:schemeClr val="accent1"/>
-          </a:lnRef>
-          <a:fillRef idx="3">
-            <a:schemeClr val="accent1"/>
-          </a:fillRef>
-          <a:effectRef idx="2">
-            <a:schemeClr val="accent1"/>
-          </a:effectRef>
-          <a:fontRef idx="minor">
-            <a:schemeClr val="lt1"/>
-          </a:fontRef>
-        </p:style>
-        <p:txBody>
-          <a:bodyPr rtlCol="0" anchor="ctr" wrap="none"/>
-          <a:lstStyle/>
-          <a:p>
-            <a:pPr algn="ctr"/>
-            <a:r>
-              <a:rPr sz="1000" b="1">
-                <a:solidFill>
-                  <a:srgbClr val="333333"/>
-                </a:solidFill>
-              </a:rPr>
-              <a:t>F
-52×55 mm</a:t>
-            </a:r>
-          </a:p>
-        </p:txBody>
-      </p:sp>
-      <p:sp>
-        <p:nvSpPr>
-          <p:cNvPr id="8" name="fig1_G"/>
-          <p:cNvSpPr/>
-          <p:nvPr/>
-        </p:nvSpPr>
-        <p:spPr>
-          <a:xfrm>
-            <a:off x="4104000" y="3708000"/>
-            <a:ext cx="1836000" cy="1980000"/>
-          </a:xfrm>
-          <a:prstGeom prst="rect">
-            <a:avLst/>
-          </a:prstGeom>
-          <a:solidFill>
-            <a:srgbClr val="F5D0D8"/>
-          </a:solidFill>
-          <a:ln w="6350">
-            <a:solidFill>
-              <a:srgbClr val="808080"/>
-            </a:solidFill>
-          </a:ln>
-        </p:spPr>
-        <p:style>
-          <a:lnRef idx="1">
-            <a:schemeClr val="accent1"/>
-          </a:lnRef>
-          <a:fillRef idx="3">
-            <a:schemeClr val="accent1"/>
-          </a:fillRef>
-          <a:effectRef idx="2">
-            <a:schemeClr val="accent1"/>
-          </a:effectRef>
-          <a:fontRef idx="minor">
-            <a:schemeClr val="lt1"/>
-          </a:fontRef>
-        </p:style>
-        <p:txBody>
-          <a:bodyPr rtlCol="0" anchor="ctr" wrap="none"/>
-          <a:lstStyle/>
-          <a:p>
-            <a:pPr algn="ctr"/>
-            <a:r>
-              <a:rPr sz="1000" b="1">
-                <a:solidFill>
-                  <a:srgbClr val="333333"/>
-                </a:solidFill>
-              </a:rPr>
-              <a:t>G
-51×55 mm</a:t>
             </a:r>
           </a:p>
         </p:txBody>

</xml_diff>

<commit_message>
feat: layout changes for fig1
</commit_message>
<xml_diff>
--- a/figures/fig1/fig1.pptx
+++ b/figures/fig1/fig1.pptx
@@ -218,7 +218,7 @@
           <a:p>
             <a:fld id="{2AF9AB64-2C27-7A45-AE48-F5190A12FDDB}" type="datetimeFigureOut">
               <a:rPr lang="en-US" smtClean="0"/>
-              <a:t>10/16/26</a:t>
+              <a:t>10/16/2026</a:t>
             </a:fld>
             <a:endParaRPr lang="en-US"/>
           </a:p>
@@ -700,7 +700,7 @@
           <a:p>
             <a:fld id="{E6ABF4C5-BF9C-40A8-A020-04F3F3965A01}" type="datetimeFigureOut">
               <a:rPr lang="en-US" smtClean="0"/>
-              <a:t>10/16/26</a:t>
+              <a:t>10/16/2026</a:t>
             </a:fld>
             <a:endParaRPr lang="en-US"/>
           </a:p>
@@ -870,7 +870,7 @@
           <a:p>
             <a:fld id="{E6ABF4C5-BF9C-40A8-A020-04F3F3965A01}" type="datetimeFigureOut">
               <a:rPr lang="en-US" smtClean="0"/>
-              <a:t>10/16/26</a:t>
+              <a:t>10/16/2026</a:t>
             </a:fld>
             <a:endParaRPr lang="en-US"/>
           </a:p>
@@ -1050,7 +1050,7 @@
           <a:p>
             <a:fld id="{E6ABF4C5-BF9C-40A8-A020-04F3F3965A01}" type="datetimeFigureOut">
               <a:rPr lang="en-US" smtClean="0"/>
-              <a:t>10/16/26</a:t>
+              <a:t>10/16/2026</a:t>
             </a:fld>
             <a:endParaRPr lang="en-US"/>
           </a:p>
@@ -1220,7 +1220,7 @@
           <a:p>
             <a:fld id="{E6ABF4C5-BF9C-40A8-A020-04F3F3965A01}" type="datetimeFigureOut">
               <a:rPr lang="en-US" smtClean="0"/>
-              <a:t>10/16/26</a:t>
+              <a:t>10/16/2026</a:t>
             </a:fld>
             <a:endParaRPr lang="en-US"/>
           </a:p>
@@ -1466,7 +1466,7 @@
           <a:p>
             <a:fld id="{E6ABF4C5-BF9C-40A8-A020-04F3F3965A01}" type="datetimeFigureOut">
               <a:rPr lang="en-US" smtClean="0"/>
-              <a:t>10/16/26</a:t>
+              <a:t>10/16/2026</a:t>
             </a:fld>
             <a:endParaRPr lang="en-US"/>
           </a:p>
@@ -1698,7 +1698,7 @@
           <a:p>
             <a:fld id="{E6ABF4C5-BF9C-40A8-A020-04F3F3965A01}" type="datetimeFigureOut">
               <a:rPr lang="en-US" smtClean="0"/>
-              <a:t>10/16/26</a:t>
+              <a:t>10/16/2026</a:t>
             </a:fld>
             <a:endParaRPr lang="en-US"/>
           </a:p>
@@ -2065,7 +2065,7 @@
           <a:p>
             <a:fld id="{E6ABF4C5-BF9C-40A8-A020-04F3F3965A01}" type="datetimeFigureOut">
               <a:rPr lang="en-US" smtClean="0"/>
-              <a:t>10/16/26</a:t>
+              <a:t>10/16/2026</a:t>
             </a:fld>
             <a:endParaRPr lang="en-US"/>
           </a:p>
@@ -2183,7 +2183,7 @@
           <a:p>
             <a:fld id="{E6ABF4C5-BF9C-40A8-A020-04F3F3965A01}" type="datetimeFigureOut">
               <a:rPr lang="en-US" smtClean="0"/>
-              <a:t>10/16/26</a:t>
+              <a:t>10/16/2026</a:t>
             </a:fld>
             <a:endParaRPr lang="en-US"/>
           </a:p>
@@ -2278,7 +2278,7 @@
           <a:p>
             <a:fld id="{E6ABF4C5-BF9C-40A8-A020-04F3F3965A01}" type="datetimeFigureOut">
               <a:rPr lang="en-US" smtClean="0"/>
-              <a:t>10/16/26</a:t>
+              <a:t>10/16/2026</a:t>
             </a:fld>
             <a:endParaRPr lang="en-US"/>
           </a:p>
@@ -2555,7 +2555,7 @@
           <a:p>
             <a:fld id="{E6ABF4C5-BF9C-40A8-A020-04F3F3965A01}" type="datetimeFigureOut">
               <a:rPr lang="en-US" smtClean="0"/>
-              <a:t>10/16/26</a:t>
+              <a:t>10/16/2026</a:t>
             </a:fld>
             <a:endParaRPr lang="en-US"/>
           </a:p>
@@ -2812,7 +2812,7 @@
           <a:p>
             <a:fld id="{E6ABF4C5-BF9C-40A8-A020-04F3F3965A01}" type="datetimeFigureOut">
               <a:rPr lang="en-US" smtClean="0"/>
-              <a:t>10/16/26</a:t>
+              <a:t>10/16/2026</a:t>
             </a:fld>
             <a:endParaRPr lang="en-US"/>
           </a:p>
@@ -3025,7 +3025,7 @@
           <a:p>
             <a:fld id="{E6ABF4C5-BF9C-40A8-A020-04F3F3965A01}" type="datetimeFigureOut">
               <a:rPr lang="en-US" smtClean="0"/>
-              <a:t>10/16/26</a:t>
+              <a:t>10/16/2026</a:t>
             </a:fld>
             <a:endParaRPr lang="en-US"/>
           </a:p>
@@ -3450,8 +3450,8 @@
         </p:nvSpPr>
         <p:spPr>
           <a:xfrm>
-            <a:off x="457200" y="457200"/>
-            <a:ext cx="3177153" cy="1653119"/>
+            <a:off x="457200" y="457201"/>
+            <a:ext cx="3177153" cy="1303020"/>
           </a:xfrm>
           <a:prstGeom prst="rect">
             <a:avLst/>
@@ -3504,8 +3504,8 @@
         </p:nvSpPr>
         <p:spPr>
           <a:xfrm>
-            <a:off x="457200" y="2123593"/>
-            <a:ext cx="2315798" cy="2557165"/>
+            <a:off x="457200" y="1760221"/>
+            <a:ext cx="2315798" cy="2920537"/>
           </a:xfrm>
           <a:prstGeom prst="rect">
             <a:avLst/>
@@ -4356,7 +4356,7 @@
       </p:sp>
       <p:sp>
         <p:nvSpPr>
-          <p:cNvPr id="34" name="fig1_C">
+          <p:cNvPr id="34" name="fig1_D">
             <a:extLst>
               <a:ext uri="{FF2B5EF4-FFF2-40B4-BE49-F238E27FC236}">
                 <a16:creationId xmlns:a16="http://schemas.microsoft.com/office/drawing/2014/main" id="{24E5BCC2-7E0F-D286-C810-3EE8B6DAFAF0}"/>
@@ -4368,7 +4368,7 @@
         </p:nvSpPr>
         <p:spPr>
           <a:xfrm>
-            <a:off x="2789466" y="2123593"/>
+            <a:off x="2781234" y="3058143"/>
             <a:ext cx="844883" cy="804892"/>
           </a:xfrm>
           <a:prstGeom prst="rect">
@@ -4403,14 +4403,14 @@
                   <a:schemeClr val="tx1"/>
                 </a:solidFill>
               </a:rPr>
-              <a:t>C</a:t>
-            </a:r>
-          </a:p>
-        </p:txBody>
-      </p:sp>
-      <p:sp>
-        <p:nvSpPr>
-          <p:cNvPr id="35" name="fig1_D">
+              <a:t>D</a:t>
+            </a:r>
+          </a:p>
+        </p:txBody>
+      </p:sp>
+      <p:sp>
+        <p:nvSpPr>
+          <p:cNvPr id="35" name="fig1_E">
             <a:extLst>
               <a:ext uri="{FF2B5EF4-FFF2-40B4-BE49-F238E27FC236}">
                 <a16:creationId xmlns:a16="http://schemas.microsoft.com/office/drawing/2014/main" id="{F4B1E1FB-07B4-88CB-999F-887A4141C55B}"/>
@@ -4422,7 +4422,7 @@
         </p:nvSpPr>
         <p:spPr>
           <a:xfrm>
-            <a:off x="2785652" y="2989424"/>
+            <a:off x="2781234" y="3875866"/>
             <a:ext cx="852510" cy="804892"/>
           </a:xfrm>
           <a:prstGeom prst="rect">
@@ -4457,14 +4457,14 @@
                   <a:schemeClr val="tx1"/>
                 </a:solidFill>
               </a:rPr>
-              <a:t>D</a:t>
-            </a:r>
-          </a:p>
-        </p:txBody>
-      </p:sp>
-      <p:sp>
-        <p:nvSpPr>
-          <p:cNvPr id="36" name="fig1_E">
+              <a:t>E</a:t>
+            </a:r>
+          </a:p>
+        </p:txBody>
+      </p:sp>
+      <p:sp>
+        <p:nvSpPr>
+          <p:cNvPr id="36" name="fig1_C">
             <a:extLst>
               <a:ext uri="{FF2B5EF4-FFF2-40B4-BE49-F238E27FC236}">
                 <a16:creationId xmlns:a16="http://schemas.microsoft.com/office/drawing/2014/main" id="{762D5EEB-8E7C-296E-BD16-4EC126DD9A92}"/>
@@ -4476,8 +4476,8 @@
         </p:nvSpPr>
         <p:spPr>
           <a:xfrm>
-            <a:off x="2789466" y="3855255"/>
-            <a:ext cx="844883" cy="825503"/>
+            <a:off x="2781234" y="1775440"/>
+            <a:ext cx="844883" cy="1282703"/>
           </a:xfrm>
           <a:prstGeom prst="rect">
             <a:avLst/>
@@ -4511,7 +4511,7 @@
                   <a:schemeClr val="tx1"/>
                 </a:solidFill>
               </a:rPr>
-              <a:t>E</a:t>
+              <a:t>C</a:t>
             </a:r>
           </a:p>
         </p:txBody>

</xml_diff>

<commit_message>
feat: changes in panels fig1
</commit_message>
<xml_diff>
--- a/figures/fig1/fig1.pptx
+++ b/figures/fig1/fig1.pptx
@@ -3450,8 +3450,8 @@
         </p:nvSpPr>
         <p:spPr>
           <a:xfrm>
-            <a:off x="457200" y="457201"/>
-            <a:ext cx="3177153" cy="1303020"/>
+            <a:off x="457200" y="457200"/>
+            <a:ext cx="3177153" cy="1448689"/>
           </a:xfrm>
           <a:prstGeom prst="rect">
             <a:avLst/>
@@ -3504,8 +3504,8 @@
         </p:nvSpPr>
         <p:spPr>
           <a:xfrm>
-            <a:off x="457200" y="1760221"/>
-            <a:ext cx="2315798" cy="2920537"/>
+            <a:off x="457200" y="1918721"/>
+            <a:ext cx="2315798" cy="2762037"/>
           </a:xfrm>
           <a:prstGeom prst="rect">
             <a:avLst/>
@@ -4476,8 +4476,8 @@
         </p:nvSpPr>
         <p:spPr>
           <a:xfrm>
-            <a:off x="2781234" y="1775440"/>
-            <a:ext cx="844883" cy="1282703"/>
+            <a:off x="2781234" y="1918721"/>
+            <a:ext cx="844883" cy="1139422"/>
           </a:xfrm>
           <a:prstGeom prst="rect">
             <a:avLst/>

</xml_diff>